<commit_message>
Add learning note for how to design a good AI agent.
</commit_message>
<xml_diff>
--- a/all-about-agent.pptx
+++ b/all-about-agent.pptx
@@ -5,7 +5,7 @@
     <p:sldMasterId id="2147483648" r:id="rId1"/>
   </p:sldMasterIdLst>
   <p:notesMasterIdLst>
-    <p:notesMasterId r:id="rId15"/>
+    <p:notesMasterId r:id="rId20"/>
   </p:notesMasterIdLst>
   <p:sldIdLst>
     <p:sldId id="431" r:id="rId2"/>
@@ -21,6 +21,11 @@
     <p:sldId id="437" r:id="rId12"/>
     <p:sldId id="438" r:id="rId13"/>
     <p:sldId id="442" r:id="rId14"/>
+    <p:sldId id="445" r:id="rId15"/>
+    <p:sldId id="444" r:id="rId16"/>
+    <p:sldId id="446" r:id="rId17"/>
+    <p:sldId id="447" r:id="rId18"/>
+    <p:sldId id="448" r:id="rId19"/>
   </p:sldIdLst>
   <p:sldSz cx="12192000" cy="6858000"/>
   <p:notesSz cx="6858000" cy="9144000"/>
@@ -927,6 +932,466 @@
     <p:extLst>
       <p:ext uri="{BB962C8B-B14F-4D97-AF65-F5344CB8AC3E}">
         <p14:creationId xmlns:p14="http://schemas.microsoft.com/office/powerpoint/2010/main" val="2438454991"/>
+      </p:ext>
+    </p:extLst>
+  </p:cSld>
+  <p:clrMapOvr>
+    <a:masterClrMapping/>
+  </p:clrMapOvr>
+</p:notes>
+</file>
+
+<file path=ppt/notesSlides/notesSlide13.xml><?xml version="1.0" encoding="utf-8"?>
+<p:notes xmlns:a="http://schemas.openxmlformats.org/drawingml/2006/main" xmlns:r="http://schemas.openxmlformats.org/officeDocument/2006/relationships" xmlns:p="http://schemas.openxmlformats.org/presentationml/2006/main">
+  <p:cSld>
+    <p:spTree>
+      <p:nvGrpSpPr>
+        <p:cNvPr id="1" name="">
+          <a:extLst>
+            <a:ext uri="{FF2B5EF4-FFF2-40B4-BE49-F238E27FC236}">
+              <a16:creationId xmlns:a16="http://schemas.microsoft.com/office/drawing/2014/main" id="{1B8BDDDE-016D-01AE-5479-9CA02F67715C}"/>
+            </a:ext>
+          </a:extLst>
+        </p:cNvPr>
+        <p:cNvGrpSpPr/>
+        <p:nvPr/>
+      </p:nvGrpSpPr>
+      <p:grpSpPr>
+        <a:xfrm>
+          <a:off x="0" y="0"/>
+          <a:ext cx="0" cy="0"/>
+          <a:chOff x="0" y="0"/>
+          <a:chExt cx="0" cy="0"/>
+        </a:xfrm>
+      </p:grpSpPr>
+      <p:sp>
+        <p:nvSpPr>
+          <p:cNvPr id="2" name="幻灯片图像占位符 1">
+            <a:extLst>
+              <a:ext uri="{FF2B5EF4-FFF2-40B4-BE49-F238E27FC236}">
+                <a16:creationId xmlns:a16="http://schemas.microsoft.com/office/drawing/2014/main" id="{27C1B576-DE02-4103-71EA-3C20669179C0}"/>
+              </a:ext>
+            </a:extLst>
+          </p:cNvPr>
+          <p:cNvSpPr>
+            <a:spLocks noGrp="1" noRot="1" noChangeAspect="1"/>
+          </p:cNvSpPr>
+          <p:nvPr>
+            <p:ph type="sldImg"/>
+          </p:nvPr>
+        </p:nvSpPr>
+        <p:spPr/>
+        <p:txBody>
+          <a:bodyPr/>
+          <a:lstStyle/>
+          <a:p>
+            <a:endParaRPr lang="zh-CN" altLang="en-US"/>
+          </a:p>
+        </p:txBody>
+      </p:sp>
+      <p:sp>
+        <p:nvSpPr>
+          <p:cNvPr id="3" name="备注占位符 2">
+            <a:extLst>
+              <a:ext uri="{FF2B5EF4-FFF2-40B4-BE49-F238E27FC236}">
+                <a16:creationId xmlns:a16="http://schemas.microsoft.com/office/drawing/2014/main" id="{8F2F9189-EFEF-4671-15C6-D2CBD1ABD34E}"/>
+              </a:ext>
+            </a:extLst>
+          </p:cNvPr>
+          <p:cNvSpPr>
+            <a:spLocks noGrp="1"/>
+          </p:cNvSpPr>
+          <p:nvPr>
+            <p:ph type="body" idx="1"/>
+          </p:nvPr>
+        </p:nvSpPr>
+        <p:spPr/>
+        <p:txBody>
+          <a:bodyPr/>
+          <a:lstStyle/>
+          <a:p>
+            <a:endParaRPr lang="zh-CN" altLang="en-US" dirty="0"/>
+          </a:p>
+        </p:txBody>
+      </p:sp>
+      <p:sp>
+        <p:nvSpPr>
+          <p:cNvPr id="4" name="灯片编号占位符 3">
+            <a:extLst>
+              <a:ext uri="{FF2B5EF4-FFF2-40B4-BE49-F238E27FC236}">
+                <a16:creationId xmlns:a16="http://schemas.microsoft.com/office/drawing/2014/main" id="{C6CA68C5-F7C4-F65C-E2A5-3C4FE4FB88C3}"/>
+              </a:ext>
+            </a:extLst>
+          </p:cNvPr>
+          <p:cNvSpPr>
+            <a:spLocks noGrp="1"/>
+          </p:cNvSpPr>
+          <p:nvPr>
+            <p:ph type="sldNum" sz="quarter" idx="5"/>
+          </p:nvPr>
+        </p:nvSpPr>
+        <p:spPr/>
+        <p:txBody>
+          <a:bodyPr/>
+          <a:lstStyle/>
+          <a:p>
+            <a:fld id="{00DCDB35-2E4E-4B7B-B6F4-40EA9C73117F}" type="slidenum">
+              <a:rPr lang="zh-CN" altLang="en-US" smtClean="0"/>
+              <a:t>15</a:t>
+            </a:fld>
+            <a:endParaRPr lang="zh-CN" altLang="en-US"/>
+          </a:p>
+        </p:txBody>
+      </p:sp>
+    </p:spTree>
+    <p:extLst>
+      <p:ext uri="{BB962C8B-B14F-4D97-AF65-F5344CB8AC3E}">
+        <p14:creationId xmlns:p14="http://schemas.microsoft.com/office/powerpoint/2010/main" val="3709081301"/>
+      </p:ext>
+    </p:extLst>
+  </p:cSld>
+  <p:clrMapOvr>
+    <a:masterClrMapping/>
+  </p:clrMapOvr>
+</p:notes>
+</file>
+
+<file path=ppt/notesSlides/notesSlide14.xml><?xml version="1.0" encoding="utf-8"?>
+<p:notes xmlns:a="http://schemas.openxmlformats.org/drawingml/2006/main" xmlns:r="http://schemas.openxmlformats.org/officeDocument/2006/relationships" xmlns:p="http://schemas.openxmlformats.org/presentationml/2006/main">
+  <p:cSld>
+    <p:spTree>
+      <p:nvGrpSpPr>
+        <p:cNvPr id="1" name="">
+          <a:extLst>
+            <a:ext uri="{FF2B5EF4-FFF2-40B4-BE49-F238E27FC236}">
+              <a16:creationId xmlns:a16="http://schemas.microsoft.com/office/drawing/2014/main" id="{9A3FA0BC-4D9D-B4E6-E0F4-E556CD03812C}"/>
+            </a:ext>
+          </a:extLst>
+        </p:cNvPr>
+        <p:cNvGrpSpPr/>
+        <p:nvPr/>
+      </p:nvGrpSpPr>
+      <p:grpSpPr>
+        <a:xfrm>
+          <a:off x="0" y="0"/>
+          <a:ext cx="0" cy="0"/>
+          <a:chOff x="0" y="0"/>
+          <a:chExt cx="0" cy="0"/>
+        </a:xfrm>
+      </p:grpSpPr>
+      <p:sp>
+        <p:nvSpPr>
+          <p:cNvPr id="2" name="幻灯片图像占位符 1">
+            <a:extLst>
+              <a:ext uri="{FF2B5EF4-FFF2-40B4-BE49-F238E27FC236}">
+                <a16:creationId xmlns:a16="http://schemas.microsoft.com/office/drawing/2014/main" id="{200D8E0A-D8E5-59D1-7535-A07703807B2B}"/>
+              </a:ext>
+            </a:extLst>
+          </p:cNvPr>
+          <p:cNvSpPr>
+            <a:spLocks noGrp="1" noRot="1" noChangeAspect="1"/>
+          </p:cNvSpPr>
+          <p:nvPr>
+            <p:ph type="sldImg"/>
+          </p:nvPr>
+        </p:nvSpPr>
+        <p:spPr/>
+        <p:txBody>
+          <a:bodyPr/>
+          <a:lstStyle/>
+          <a:p>
+            <a:endParaRPr lang="zh-CN" altLang="en-US"/>
+          </a:p>
+        </p:txBody>
+      </p:sp>
+      <p:sp>
+        <p:nvSpPr>
+          <p:cNvPr id="3" name="备注占位符 2">
+            <a:extLst>
+              <a:ext uri="{FF2B5EF4-FFF2-40B4-BE49-F238E27FC236}">
+                <a16:creationId xmlns:a16="http://schemas.microsoft.com/office/drawing/2014/main" id="{42A20C5A-C7DE-D489-ED5C-A0E725908FBD}"/>
+              </a:ext>
+            </a:extLst>
+          </p:cNvPr>
+          <p:cNvSpPr>
+            <a:spLocks noGrp="1"/>
+          </p:cNvSpPr>
+          <p:nvPr>
+            <p:ph type="body" idx="1"/>
+          </p:nvPr>
+        </p:nvSpPr>
+        <p:spPr/>
+        <p:txBody>
+          <a:bodyPr/>
+          <a:lstStyle/>
+          <a:p>
+            <a:endParaRPr lang="zh-CN" altLang="en-US" dirty="0"/>
+          </a:p>
+        </p:txBody>
+      </p:sp>
+      <p:sp>
+        <p:nvSpPr>
+          <p:cNvPr id="4" name="灯片编号占位符 3">
+            <a:extLst>
+              <a:ext uri="{FF2B5EF4-FFF2-40B4-BE49-F238E27FC236}">
+                <a16:creationId xmlns:a16="http://schemas.microsoft.com/office/drawing/2014/main" id="{65AB41D2-00AB-0B54-EEE5-0393B04272EE}"/>
+              </a:ext>
+            </a:extLst>
+          </p:cNvPr>
+          <p:cNvSpPr>
+            <a:spLocks noGrp="1"/>
+          </p:cNvSpPr>
+          <p:nvPr>
+            <p:ph type="sldNum" sz="quarter" idx="5"/>
+          </p:nvPr>
+        </p:nvSpPr>
+        <p:spPr/>
+        <p:txBody>
+          <a:bodyPr/>
+          <a:lstStyle/>
+          <a:p>
+            <a:fld id="{00DCDB35-2E4E-4B7B-B6F4-40EA9C73117F}" type="slidenum">
+              <a:rPr lang="zh-CN" altLang="en-US" smtClean="0"/>
+              <a:t>16</a:t>
+            </a:fld>
+            <a:endParaRPr lang="zh-CN" altLang="en-US"/>
+          </a:p>
+        </p:txBody>
+      </p:sp>
+    </p:spTree>
+    <p:extLst>
+      <p:ext uri="{BB962C8B-B14F-4D97-AF65-F5344CB8AC3E}">
+        <p14:creationId xmlns:p14="http://schemas.microsoft.com/office/powerpoint/2010/main" val="2353038337"/>
+      </p:ext>
+    </p:extLst>
+  </p:cSld>
+  <p:clrMapOvr>
+    <a:masterClrMapping/>
+  </p:clrMapOvr>
+</p:notes>
+</file>
+
+<file path=ppt/notesSlides/notesSlide15.xml><?xml version="1.0" encoding="utf-8"?>
+<p:notes xmlns:a="http://schemas.openxmlformats.org/drawingml/2006/main" xmlns:r="http://schemas.openxmlformats.org/officeDocument/2006/relationships" xmlns:p="http://schemas.openxmlformats.org/presentationml/2006/main">
+  <p:cSld>
+    <p:spTree>
+      <p:nvGrpSpPr>
+        <p:cNvPr id="1" name="">
+          <a:extLst>
+            <a:ext uri="{FF2B5EF4-FFF2-40B4-BE49-F238E27FC236}">
+              <a16:creationId xmlns:a16="http://schemas.microsoft.com/office/drawing/2014/main" id="{9B07C438-6354-DE9D-34AC-4560D388A247}"/>
+            </a:ext>
+          </a:extLst>
+        </p:cNvPr>
+        <p:cNvGrpSpPr/>
+        <p:nvPr/>
+      </p:nvGrpSpPr>
+      <p:grpSpPr>
+        <a:xfrm>
+          <a:off x="0" y="0"/>
+          <a:ext cx="0" cy="0"/>
+          <a:chOff x="0" y="0"/>
+          <a:chExt cx="0" cy="0"/>
+        </a:xfrm>
+      </p:grpSpPr>
+      <p:sp>
+        <p:nvSpPr>
+          <p:cNvPr id="2" name="幻灯片图像占位符 1">
+            <a:extLst>
+              <a:ext uri="{FF2B5EF4-FFF2-40B4-BE49-F238E27FC236}">
+                <a16:creationId xmlns:a16="http://schemas.microsoft.com/office/drawing/2014/main" id="{90D4039C-6673-5F10-594B-0EECB45A6411}"/>
+              </a:ext>
+            </a:extLst>
+          </p:cNvPr>
+          <p:cNvSpPr>
+            <a:spLocks noGrp="1" noRot="1" noChangeAspect="1"/>
+          </p:cNvSpPr>
+          <p:nvPr>
+            <p:ph type="sldImg"/>
+          </p:nvPr>
+        </p:nvSpPr>
+        <p:spPr/>
+        <p:txBody>
+          <a:bodyPr/>
+          <a:lstStyle/>
+          <a:p>
+            <a:endParaRPr lang="zh-CN" altLang="en-US"/>
+          </a:p>
+        </p:txBody>
+      </p:sp>
+      <p:sp>
+        <p:nvSpPr>
+          <p:cNvPr id="3" name="备注占位符 2">
+            <a:extLst>
+              <a:ext uri="{FF2B5EF4-FFF2-40B4-BE49-F238E27FC236}">
+                <a16:creationId xmlns:a16="http://schemas.microsoft.com/office/drawing/2014/main" id="{AB3C6EBB-F4F7-BD17-ED2F-2056CF9D67F4}"/>
+              </a:ext>
+            </a:extLst>
+          </p:cNvPr>
+          <p:cNvSpPr>
+            <a:spLocks noGrp="1"/>
+          </p:cNvSpPr>
+          <p:nvPr>
+            <p:ph type="body" idx="1"/>
+          </p:nvPr>
+        </p:nvSpPr>
+        <p:spPr/>
+        <p:txBody>
+          <a:bodyPr/>
+          <a:lstStyle/>
+          <a:p>
+            <a:endParaRPr lang="zh-CN" altLang="en-US" dirty="0"/>
+          </a:p>
+        </p:txBody>
+      </p:sp>
+      <p:sp>
+        <p:nvSpPr>
+          <p:cNvPr id="4" name="灯片编号占位符 3">
+            <a:extLst>
+              <a:ext uri="{FF2B5EF4-FFF2-40B4-BE49-F238E27FC236}">
+                <a16:creationId xmlns:a16="http://schemas.microsoft.com/office/drawing/2014/main" id="{ADBC482D-6D41-EEF5-A7E6-C59FB8602809}"/>
+              </a:ext>
+            </a:extLst>
+          </p:cNvPr>
+          <p:cNvSpPr>
+            <a:spLocks noGrp="1"/>
+          </p:cNvSpPr>
+          <p:nvPr>
+            <p:ph type="sldNum" sz="quarter" idx="5"/>
+          </p:nvPr>
+        </p:nvSpPr>
+        <p:spPr/>
+        <p:txBody>
+          <a:bodyPr/>
+          <a:lstStyle/>
+          <a:p>
+            <a:fld id="{00DCDB35-2E4E-4B7B-B6F4-40EA9C73117F}" type="slidenum">
+              <a:rPr lang="zh-CN" altLang="en-US" smtClean="0"/>
+              <a:t>17</a:t>
+            </a:fld>
+            <a:endParaRPr lang="zh-CN" altLang="en-US"/>
+          </a:p>
+        </p:txBody>
+      </p:sp>
+    </p:spTree>
+    <p:extLst>
+      <p:ext uri="{BB962C8B-B14F-4D97-AF65-F5344CB8AC3E}">
+        <p14:creationId xmlns:p14="http://schemas.microsoft.com/office/powerpoint/2010/main" val="1935933310"/>
+      </p:ext>
+    </p:extLst>
+  </p:cSld>
+  <p:clrMapOvr>
+    <a:masterClrMapping/>
+  </p:clrMapOvr>
+</p:notes>
+</file>
+
+<file path=ppt/notesSlides/notesSlide16.xml><?xml version="1.0" encoding="utf-8"?>
+<p:notes xmlns:a="http://schemas.openxmlformats.org/drawingml/2006/main" xmlns:r="http://schemas.openxmlformats.org/officeDocument/2006/relationships" xmlns:p="http://schemas.openxmlformats.org/presentationml/2006/main">
+  <p:cSld>
+    <p:spTree>
+      <p:nvGrpSpPr>
+        <p:cNvPr id="1" name="">
+          <a:extLst>
+            <a:ext uri="{FF2B5EF4-FFF2-40B4-BE49-F238E27FC236}">
+              <a16:creationId xmlns:a16="http://schemas.microsoft.com/office/drawing/2014/main" id="{AD7EE9B1-6E8C-8AE8-8921-EBBD49C29127}"/>
+            </a:ext>
+          </a:extLst>
+        </p:cNvPr>
+        <p:cNvGrpSpPr/>
+        <p:nvPr/>
+      </p:nvGrpSpPr>
+      <p:grpSpPr>
+        <a:xfrm>
+          <a:off x="0" y="0"/>
+          <a:ext cx="0" cy="0"/>
+          <a:chOff x="0" y="0"/>
+          <a:chExt cx="0" cy="0"/>
+        </a:xfrm>
+      </p:grpSpPr>
+      <p:sp>
+        <p:nvSpPr>
+          <p:cNvPr id="2" name="幻灯片图像占位符 1">
+            <a:extLst>
+              <a:ext uri="{FF2B5EF4-FFF2-40B4-BE49-F238E27FC236}">
+                <a16:creationId xmlns:a16="http://schemas.microsoft.com/office/drawing/2014/main" id="{F06A3B66-5198-C7A8-1A68-8632FD88BFF6}"/>
+              </a:ext>
+            </a:extLst>
+          </p:cNvPr>
+          <p:cNvSpPr>
+            <a:spLocks noGrp="1" noRot="1" noChangeAspect="1"/>
+          </p:cNvSpPr>
+          <p:nvPr>
+            <p:ph type="sldImg"/>
+          </p:nvPr>
+        </p:nvSpPr>
+        <p:spPr/>
+        <p:txBody>
+          <a:bodyPr/>
+          <a:lstStyle/>
+          <a:p>
+            <a:endParaRPr lang="zh-CN" altLang="en-US"/>
+          </a:p>
+        </p:txBody>
+      </p:sp>
+      <p:sp>
+        <p:nvSpPr>
+          <p:cNvPr id="3" name="备注占位符 2">
+            <a:extLst>
+              <a:ext uri="{FF2B5EF4-FFF2-40B4-BE49-F238E27FC236}">
+                <a16:creationId xmlns:a16="http://schemas.microsoft.com/office/drawing/2014/main" id="{FA8E7C2D-4539-7C74-A70D-9FFA0257C1BE}"/>
+              </a:ext>
+            </a:extLst>
+          </p:cNvPr>
+          <p:cNvSpPr>
+            <a:spLocks noGrp="1"/>
+          </p:cNvSpPr>
+          <p:nvPr>
+            <p:ph type="body" idx="1"/>
+          </p:nvPr>
+        </p:nvSpPr>
+        <p:spPr/>
+        <p:txBody>
+          <a:bodyPr/>
+          <a:lstStyle/>
+          <a:p>
+            <a:endParaRPr lang="zh-CN" altLang="en-US" dirty="0"/>
+          </a:p>
+        </p:txBody>
+      </p:sp>
+      <p:sp>
+        <p:nvSpPr>
+          <p:cNvPr id="4" name="灯片编号占位符 3">
+            <a:extLst>
+              <a:ext uri="{FF2B5EF4-FFF2-40B4-BE49-F238E27FC236}">
+                <a16:creationId xmlns:a16="http://schemas.microsoft.com/office/drawing/2014/main" id="{8F558F27-BF27-149B-9C61-A75D572723A3}"/>
+              </a:ext>
+            </a:extLst>
+          </p:cNvPr>
+          <p:cNvSpPr>
+            <a:spLocks noGrp="1"/>
+          </p:cNvSpPr>
+          <p:nvPr>
+            <p:ph type="sldNum" sz="quarter" idx="5"/>
+          </p:nvPr>
+        </p:nvSpPr>
+        <p:spPr/>
+        <p:txBody>
+          <a:bodyPr/>
+          <a:lstStyle/>
+          <a:p>
+            <a:fld id="{00DCDB35-2E4E-4B7B-B6F4-40EA9C73117F}" type="slidenum">
+              <a:rPr lang="zh-CN" altLang="en-US" smtClean="0"/>
+              <a:t>18</a:t>
+            </a:fld>
+            <a:endParaRPr lang="zh-CN" altLang="en-US"/>
+          </a:p>
+        </p:txBody>
+      </p:sp>
+    </p:spTree>
+    <p:extLst>
+      <p:ext uri="{BB962C8B-B14F-4D97-AF65-F5344CB8AC3E}">
+        <p14:creationId xmlns:p14="http://schemas.microsoft.com/office/powerpoint/2010/main" val="2134234177"/>
       </p:ext>
     </p:extLst>
   </p:cSld>
@@ -5336,15 +5801,7 @@
           <a:p>
             <a:r>
               <a:rPr lang="en-US" altLang="zh-CN" dirty="0"/>
-              <a:t>All about AI Agent -</a:t>
-            </a:r>
-            <a:r>
-              <a:rPr lang="zh-CN" altLang="en-US" dirty="0"/>
-              <a:t>智能体技术发展报告</a:t>
-            </a:r>
-            <a:r>
-              <a:rPr lang="en-US" altLang="zh-CN" dirty="0"/>
-              <a:t>.pdf</a:t>
+              <a:t>All about AI Agent</a:t>
             </a:r>
             <a:endParaRPr lang="zh-CN" altLang="en-US" dirty="0"/>
           </a:p>
@@ -6259,6 +6716,973 @@
     <p:extLst>
       <p:ext uri="{BB962C8B-B14F-4D97-AF65-F5344CB8AC3E}">
         <p14:creationId xmlns:p14="http://schemas.microsoft.com/office/powerpoint/2010/main" val="667362291"/>
+      </p:ext>
+    </p:extLst>
+  </p:cSld>
+  <p:clrMapOvr>
+    <a:masterClrMapping/>
+  </p:clrMapOvr>
+</p:sld>
+</file>
+
+<file path=ppt/slides/slide14.xml><?xml version="1.0" encoding="utf-8"?>
+<p:sld xmlns:a="http://schemas.openxmlformats.org/drawingml/2006/main" xmlns:r="http://schemas.openxmlformats.org/officeDocument/2006/relationships" xmlns:p="http://schemas.openxmlformats.org/presentationml/2006/main">
+  <p:cSld>
+    <p:spTree>
+      <p:nvGrpSpPr>
+        <p:cNvPr id="1" name="">
+          <a:extLst>
+            <a:ext uri="{FF2B5EF4-FFF2-40B4-BE49-F238E27FC236}">
+              <a16:creationId xmlns:a16="http://schemas.microsoft.com/office/drawing/2014/main" id="{B8BBC5F0-61D9-71F0-DE44-ED73EAF6795B}"/>
+            </a:ext>
+          </a:extLst>
+        </p:cNvPr>
+        <p:cNvGrpSpPr/>
+        <p:nvPr/>
+      </p:nvGrpSpPr>
+      <p:grpSpPr>
+        <a:xfrm>
+          <a:off x="0" y="0"/>
+          <a:ext cx="0" cy="0"/>
+          <a:chOff x="0" y="0"/>
+          <a:chExt cx="0" cy="0"/>
+        </a:xfrm>
+      </p:grpSpPr>
+      <p:sp>
+        <p:nvSpPr>
+          <p:cNvPr id="2" name="标题 1">
+            <a:extLst>
+              <a:ext uri="{FF2B5EF4-FFF2-40B4-BE49-F238E27FC236}">
+                <a16:creationId xmlns:a16="http://schemas.microsoft.com/office/drawing/2014/main" id="{E57FC2FA-289A-9DDF-1ECC-2B69D7838731}"/>
+              </a:ext>
+            </a:extLst>
+          </p:cNvPr>
+          <p:cNvSpPr>
+            <a:spLocks noGrp="1"/>
+          </p:cNvSpPr>
+          <p:nvPr>
+            <p:ph type="ctrTitle"/>
+          </p:nvPr>
+        </p:nvSpPr>
+        <p:spPr>
+          <a:xfrm>
+            <a:off x="1310072" y="1122363"/>
+            <a:ext cx="9571856" cy="2387600"/>
+          </a:xfrm>
+        </p:spPr>
+        <p:txBody>
+          <a:bodyPr/>
+          <a:lstStyle/>
+          <a:p>
+            <a:r>
+              <a:rPr lang="en-US" altLang="zh-CN" dirty="0"/>
+              <a:t>AI Agent</a:t>
+            </a:r>
+            <a:endParaRPr lang="zh-CN" altLang="en-US" dirty="0"/>
+          </a:p>
+        </p:txBody>
+      </p:sp>
+      <p:sp>
+        <p:nvSpPr>
+          <p:cNvPr id="3" name="副标题 2">
+            <a:extLst>
+              <a:ext uri="{FF2B5EF4-FFF2-40B4-BE49-F238E27FC236}">
+                <a16:creationId xmlns:a16="http://schemas.microsoft.com/office/drawing/2014/main" id="{AD70AEA3-1753-D1CB-ACA9-F38C74D9166E}"/>
+              </a:ext>
+            </a:extLst>
+          </p:cNvPr>
+          <p:cNvSpPr>
+            <a:spLocks noGrp="1"/>
+          </p:cNvSpPr>
+          <p:nvPr>
+            <p:ph type="subTitle" idx="1"/>
+          </p:nvPr>
+        </p:nvSpPr>
+        <p:spPr/>
+        <p:txBody>
+          <a:bodyPr/>
+          <a:lstStyle/>
+          <a:p>
+            <a:r>
+              <a:rPr lang="en-US" altLang="zh-CN" dirty="0"/>
+              <a:t>How to design a good/useful agent or vertical agent</a:t>
+            </a:r>
+          </a:p>
+        </p:txBody>
+      </p:sp>
+    </p:spTree>
+    <p:extLst>
+      <p:ext uri="{BB962C8B-B14F-4D97-AF65-F5344CB8AC3E}">
+        <p14:creationId xmlns:p14="http://schemas.microsoft.com/office/powerpoint/2010/main" val="359134761"/>
+      </p:ext>
+    </p:extLst>
+  </p:cSld>
+  <p:clrMapOvr>
+    <a:masterClrMapping/>
+  </p:clrMapOvr>
+</p:sld>
+</file>
+
+<file path=ppt/slides/slide15.xml><?xml version="1.0" encoding="utf-8"?>
+<p:sld xmlns:a="http://schemas.openxmlformats.org/drawingml/2006/main" xmlns:r="http://schemas.openxmlformats.org/officeDocument/2006/relationships" xmlns:p="http://schemas.openxmlformats.org/presentationml/2006/main">
+  <p:cSld>
+    <p:spTree>
+      <p:nvGrpSpPr>
+        <p:cNvPr id="1" name="">
+          <a:extLst>
+            <a:ext uri="{FF2B5EF4-FFF2-40B4-BE49-F238E27FC236}">
+              <a16:creationId xmlns:a16="http://schemas.microsoft.com/office/drawing/2014/main" id="{A2DCA5A0-D5AA-CA8B-5747-2541AAE6C64F}"/>
+            </a:ext>
+          </a:extLst>
+        </p:cNvPr>
+        <p:cNvGrpSpPr/>
+        <p:nvPr/>
+      </p:nvGrpSpPr>
+      <p:grpSpPr>
+        <a:xfrm>
+          <a:off x="0" y="0"/>
+          <a:ext cx="0" cy="0"/>
+          <a:chOff x="0" y="0"/>
+          <a:chExt cx="0" cy="0"/>
+        </a:xfrm>
+      </p:grpSpPr>
+      <p:sp>
+        <p:nvSpPr>
+          <p:cNvPr id="2" name="标题 1">
+            <a:extLst>
+              <a:ext uri="{FF2B5EF4-FFF2-40B4-BE49-F238E27FC236}">
+                <a16:creationId xmlns:a16="http://schemas.microsoft.com/office/drawing/2014/main" id="{A3C81FE4-8909-5F77-CAD3-36B83197E8AB}"/>
+              </a:ext>
+            </a:extLst>
+          </p:cNvPr>
+          <p:cNvSpPr>
+            <a:spLocks noGrp="1"/>
+          </p:cNvSpPr>
+          <p:nvPr>
+            <p:ph type="title"/>
+          </p:nvPr>
+        </p:nvSpPr>
+        <p:spPr>
+          <a:xfrm>
+            <a:off x="838200" y="125639"/>
+            <a:ext cx="10515600" cy="1325563"/>
+          </a:xfrm>
+        </p:spPr>
+        <p:txBody>
+          <a:bodyPr/>
+          <a:lstStyle/>
+          <a:p>
+            <a:r>
+              <a:rPr lang="en-US" altLang="zh-CN" dirty="0"/>
+              <a:t>Key Notes to Always Remember</a:t>
+            </a:r>
+          </a:p>
+        </p:txBody>
+      </p:sp>
+      <p:sp>
+        <p:nvSpPr>
+          <p:cNvPr id="6" name="文本框 5">
+            <a:extLst>
+              <a:ext uri="{FF2B5EF4-FFF2-40B4-BE49-F238E27FC236}">
+                <a16:creationId xmlns:a16="http://schemas.microsoft.com/office/drawing/2014/main" id="{EC6EE387-F5BB-7736-CE04-15E2568F6A3E}"/>
+              </a:ext>
+            </a:extLst>
+          </p:cNvPr>
+          <p:cNvSpPr txBox="1"/>
+          <p:nvPr/>
+        </p:nvSpPr>
+        <p:spPr>
+          <a:xfrm>
+            <a:off x="955503" y="1381794"/>
+            <a:ext cx="10769601" cy="2543132"/>
+          </a:xfrm>
+          <a:prstGeom prst="rect">
+            <a:avLst/>
+          </a:prstGeom>
+          <a:noFill/>
+        </p:spPr>
+        <p:txBody>
+          <a:bodyPr wrap="square">
+            <a:spAutoFit/>
+          </a:bodyPr>
+          <a:lstStyle/>
+          <a:p>
+            <a:pPr marL="285750" indent="-285750">
+              <a:lnSpc>
+                <a:spcPct val="150000"/>
+              </a:lnSpc>
+              <a:buFont typeface="Arial" panose="020B0604020202020204" pitchFamily="34" charset="0"/>
+              <a:buChar char="•"/>
+            </a:pPr>
+            <a:r>
+              <a:rPr lang="en-US" altLang="zh-CN" dirty="0"/>
+              <a:t>The LLM is the only actor that decides anything. </a:t>
+            </a:r>
+          </a:p>
+          <a:p>
+            <a:pPr marL="742950" lvl="1" indent="-285750">
+              <a:lnSpc>
+                <a:spcPct val="150000"/>
+              </a:lnSpc>
+              <a:buFont typeface="Arial" panose="020B0604020202020204" pitchFamily="34" charset="0"/>
+              <a:buChar char="•"/>
+            </a:pPr>
+            <a:r>
+              <a:rPr lang="en-US" altLang="zh-CN" dirty="0"/>
+              <a:t>Every plan, branch, and tool choice ultimately comes from the model.</a:t>
+            </a:r>
+          </a:p>
+          <a:p>
+            <a:pPr marL="285750" indent="-285750">
+              <a:lnSpc>
+                <a:spcPct val="150000"/>
+              </a:lnSpc>
+              <a:buFont typeface="Arial" panose="020B0604020202020204" pitchFamily="34" charset="0"/>
+              <a:buChar char="•"/>
+            </a:pPr>
+            <a:endParaRPr lang="en-US" altLang="zh-CN" dirty="0"/>
+          </a:p>
+          <a:p>
+            <a:pPr marL="285750" indent="-285750">
+              <a:lnSpc>
+                <a:spcPct val="150000"/>
+              </a:lnSpc>
+              <a:buFont typeface="Arial" panose="020B0604020202020204" pitchFamily="34" charset="0"/>
+              <a:buChar char="•"/>
+            </a:pPr>
+            <a:r>
+              <a:rPr lang="en-US" altLang="zh-CN" dirty="0"/>
+              <a:t>Agent engineering/Harness = managing the context window the LLM sees and formulate the actions LLM perform. </a:t>
+            </a:r>
+          </a:p>
+          <a:p>
+            <a:pPr marL="742950" lvl="1" indent="-285750">
+              <a:lnSpc>
+                <a:spcPct val="150000"/>
+              </a:lnSpc>
+              <a:buFont typeface="Arial" panose="020B0604020202020204" pitchFamily="34" charset="0"/>
+              <a:buChar char="•"/>
+            </a:pPr>
+            <a:r>
+              <a:rPr lang="en-US" altLang="zh-CN" dirty="0"/>
+              <a:t>The goal is to make non-deterministic LLM output more deterministic and more useful.</a:t>
+            </a:r>
+          </a:p>
+        </p:txBody>
+      </p:sp>
+    </p:spTree>
+    <p:extLst>
+      <p:ext uri="{BB962C8B-B14F-4D97-AF65-F5344CB8AC3E}">
+        <p14:creationId xmlns:p14="http://schemas.microsoft.com/office/powerpoint/2010/main" val="791819653"/>
+      </p:ext>
+    </p:extLst>
+  </p:cSld>
+  <p:clrMapOvr>
+    <a:masterClrMapping/>
+  </p:clrMapOvr>
+</p:sld>
+</file>
+
+<file path=ppt/slides/slide16.xml><?xml version="1.0" encoding="utf-8"?>
+<p:sld xmlns:a="http://schemas.openxmlformats.org/drawingml/2006/main" xmlns:r="http://schemas.openxmlformats.org/officeDocument/2006/relationships" xmlns:p="http://schemas.openxmlformats.org/presentationml/2006/main">
+  <p:cSld>
+    <p:spTree>
+      <p:nvGrpSpPr>
+        <p:cNvPr id="1" name="">
+          <a:extLst>
+            <a:ext uri="{FF2B5EF4-FFF2-40B4-BE49-F238E27FC236}">
+              <a16:creationId xmlns:a16="http://schemas.microsoft.com/office/drawing/2014/main" id="{362E506E-6C15-47E4-254F-8B33276CBEE7}"/>
+            </a:ext>
+          </a:extLst>
+        </p:cNvPr>
+        <p:cNvGrpSpPr/>
+        <p:nvPr/>
+      </p:nvGrpSpPr>
+      <p:grpSpPr>
+        <a:xfrm>
+          <a:off x="0" y="0"/>
+          <a:ext cx="0" cy="0"/>
+          <a:chOff x="0" y="0"/>
+          <a:chExt cx="0" cy="0"/>
+        </a:xfrm>
+      </p:grpSpPr>
+      <p:sp>
+        <p:nvSpPr>
+          <p:cNvPr id="2" name="标题 1">
+            <a:extLst>
+              <a:ext uri="{FF2B5EF4-FFF2-40B4-BE49-F238E27FC236}">
+                <a16:creationId xmlns:a16="http://schemas.microsoft.com/office/drawing/2014/main" id="{770D3C81-ABBF-A6C6-6424-5CAD482080F8}"/>
+              </a:ext>
+            </a:extLst>
+          </p:cNvPr>
+          <p:cNvSpPr>
+            <a:spLocks noGrp="1"/>
+          </p:cNvSpPr>
+          <p:nvPr>
+            <p:ph type="title"/>
+          </p:nvPr>
+        </p:nvSpPr>
+        <p:spPr>
+          <a:xfrm>
+            <a:off x="838200" y="125639"/>
+            <a:ext cx="10515600" cy="1325563"/>
+          </a:xfrm>
+        </p:spPr>
+        <p:txBody>
+          <a:bodyPr/>
+          <a:lstStyle/>
+          <a:p>
+            <a:r>
+              <a:rPr lang="en-US" altLang="zh-CN" dirty="0"/>
+              <a:t>What Decides If a Vertical Agent Is Useful</a:t>
+            </a:r>
+          </a:p>
+        </p:txBody>
+      </p:sp>
+      <p:sp>
+        <p:nvSpPr>
+          <p:cNvPr id="6" name="文本框 5">
+            <a:extLst>
+              <a:ext uri="{FF2B5EF4-FFF2-40B4-BE49-F238E27FC236}">
+                <a16:creationId xmlns:a16="http://schemas.microsoft.com/office/drawing/2014/main" id="{B98DE384-824F-8AC2-6D81-DEBE65831073}"/>
+              </a:ext>
+            </a:extLst>
+          </p:cNvPr>
+          <p:cNvSpPr txBox="1"/>
+          <p:nvPr/>
+        </p:nvSpPr>
+        <p:spPr>
+          <a:xfrm>
+            <a:off x="955503" y="1381794"/>
+            <a:ext cx="10769601" cy="4205126"/>
+          </a:xfrm>
+          <a:prstGeom prst="rect">
+            <a:avLst/>
+          </a:prstGeom>
+          <a:noFill/>
+        </p:spPr>
+        <p:txBody>
+          <a:bodyPr wrap="square">
+            <a:spAutoFit/>
+          </a:bodyPr>
+          <a:lstStyle/>
+          <a:p>
+            <a:pPr marL="285750" indent="-285750">
+              <a:lnSpc>
+                <a:spcPct val="150000"/>
+              </a:lnSpc>
+              <a:buFont typeface="Arial" panose="020B0604020202020204" pitchFamily="34" charset="0"/>
+              <a:buChar char="•"/>
+            </a:pPr>
+            <a:r>
+              <a:rPr lang="en-US" altLang="zh-CN" dirty="0"/>
+              <a:t>Does it </a:t>
+            </a:r>
+            <a:r>
+              <a:rPr lang="en-US" altLang="zh-CN" b="1" dirty="0"/>
+              <a:t>lower the cost of obtaining context</a:t>
+            </a:r>
+            <a:r>
+              <a:rPr lang="en-US" altLang="zh-CN" dirty="0"/>
+              <a:t>? — Can the model reach the right files, docs, tickets, dashboards without burning turns and tokens to find them?</a:t>
+            </a:r>
+          </a:p>
+          <a:p>
+            <a:pPr marL="285750" indent="-285750">
+              <a:lnSpc>
+                <a:spcPct val="150000"/>
+              </a:lnSpc>
+              <a:buFont typeface="Arial" panose="020B0604020202020204" pitchFamily="34" charset="0"/>
+              <a:buChar char="•"/>
+            </a:pPr>
+            <a:r>
+              <a:rPr lang="en-US" altLang="zh-CN" dirty="0"/>
+              <a:t>Does it </a:t>
+            </a:r>
+            <a:r>
+              <a:rPr lang="en-US" altLang="zh-CN" b="1" dirty="0"/>
+              <a:t>improve state stability</a:t>
+            </a:r>
+            <a:r>
+              <a:rPr lang="en-US" altLang="zh-CN" dirty="0"/>
+              <a:t>? — Across a long task, does the agent's understanding of "where we are" stay coherent, or drift?</a:t>
+            </a:r>
+          </a:p>
+          <a:p>
+            <a:pPr marL="285750" indent="-285750">
+              <a:lnSpc>
+                <a:spcPct val="150000"/>
+              </a:lnSpc>
+              <a:buFont typeface="Arial" panose="020B0604020202020204" pitchFamily="34" charset="0"/>
+              <a:buChar char="•"/>
+            </a:pPr>
+            <a:r>
+              <a:rPr lang="en-US" altLang="zh-CN" dirty="0"/>
+              <a:t>Does it </a:t>
+            </a:r>
+            <a:r>
+              <a:rPr lang="en-US" altLang="zh-CN" b="1" dirty="0"/>
+              <a:t>truly understand the domain environment</a:t>
+            </a:r>
+            <a:r>
+              <a:rPr lang="en-US" altLang="zh-CN" dirty="0"/>
+              <a:t>? — Conventions, approval flows, permission boundaries, the way </a:t>
+            </a:r>
+            <a:r>
+              <a:rPr lang="en-US" altLang="zh-CN" i="1" dirty="0"/>
+              <a:t>this</a:t>
+            </a:r>
+            <a:r>
+              <a:rPr lang="en-US" altLang="zh-CN" dirty="0"/>
+              <a:t> team actually works.</a:t>
+            </a:r>
+          </a:p>
+          <a:p>
+            <a:pPr marL="285750" indent="-285750">
+              <a:lnSpc>
+                <a:spcPct val="150000"/>
+              </a:lnSpc>
+              <a:buFont typeface="Arial" panose="020B0604020202020204" pitchFamily="34" charset="0"/>
+              <a:buChar char="•"/>
+            </a:pPr>
+            <a:endParaRPr lang="en-US" altLang="zh-CN" dirty="0"/>
+          </a:p>
+          <a:p>
+            <a:pPr marL="285750" indent="-285750">
+              <a:lnSpc>
+                <a:spcPct val="150000"/>
+              </a:lnSpc>
+              <a:buFont typeface="Arial" panose="020B0604020202020204" pitchFamily="34" charset="0"/>
+              <a:buChar char="•"/>
+            </a:pPr>
+            <a:r>
+              <a:rPr lang="en-US" altLang="zh-CN" dirty="0"/>
+              <a:t>A "vertical agent" that just wraps GPT with a domain prompt and a couple of APIs hits none of these. A real one invests in retrieval, scratchpads, and domain rules until the model can operate in that environment as confidently as a seasoned engineer would.</a:t>
+            </a:r>
+          </a:p>
+        </p:txBody>
+      </p:sp>
+    </p:spTree>
+    <p:extLst>
+      <p:ext uri="{BB962C8B-B14F-4D97-AF65-F5344CB8AC3E}">
+        <p14:creationId xmlns:p14="http://schemas.microsoft.com/office/powerpoint/2010/main" val="3943382949"/>
+      </p:ext>
+    </p:extLst>
+  </p:cSld>
+  <p:clrMapOvr>
+    <a:masterClrMapping/>
+  </p:clrMapOvr>
+</p:sld>
+</file>
+
+<file path=ppt/slides/slide17.xml><?xml version="1.0" encoding="utf-8"?>
+<p:sld xmlns:a="http://schemas.openxmlformats.org/drawingml/2006/main" xmlns:r="http://schemas.openxmlformats.org/officeDocument/2006/relationships" xmlns:p="http://schemas.openxmlformats.org/presentationml/2006/main">
+  <p:cSld>
+    <p:spTree>
+      <p:nvGrpSpPr>
+        <p:cNvPr id="1" name="">
+          <a:extLst>
+            <a:ext uri="{FF2B5EF4-FFF2-40B4-BE49-F238E27FC236}">
+              <a16:creationId xmlns:a16="http://schemas.microsoft.com/office/drawing/2014/main" id="{1E82DA52-E4C5-E428-4E48-6F5E098FA047}"/>
+            </a:ext>
+          </a:extLst>
+        </p:cNvPr>
+        <p:cNvGrpSpPr/>
+        <p:nvPr/>
+      </p:nvGrpSpPr>
+      <p:grpSpPr>
+        <a:xfrm>
+          <a:off x="0" y="0"/>
+          <a:ext cx="0" cy="0"/>
+          <a:chOff x="0" y="0"/>
+          <a:chExt cx="0" cy="0"/>
+        </a:xfrm>
+      </p:grpSpPr>
+      <p:sp>
+        <p:nvSpPr>
+          <p:cNvPr id="2" name="标题 1">
+            <a:extLst>
+              <a:ext uri="{FF2B5EF4-FFF2-40B4-BE49-F238E27FC236}">
+                <a16:creationId xmlns:a16="http://schemas.microsoft.com/office/drawing/2014/main" id="{A7AB1667-0AE9-96AE-FCF4-46579AF6AAB7}"/>
+              </a:ext>
+            </a:extLst>
+          </p:cNvPr>
+          <p:cNvSpPr>
+            <a:spLocks noGrp="1"/>
+          </p:cNvSpPr>
+          <p:nvPr>
+            <p:ph type="title"/>
+          </p:nvPr>
+        </p:nvSpPr>
+        <p:spPr>
+          <a:xfrm>
+            <a:off x="838200" y="125639"/>
+            <a:ext cx="10515600" cy="1325563"/>
+          </a:xfrm>
+        </p:spPr>
+        <p:txBody>
+          <a:bodyPr/>
+          <a:lstStyle/>
+          <a:p>
+            <a:r>
+              <a:rPr lang="en-US" altLang="zh-CN" dirty="0"/>
+              <a:t>Why Claude Code Is Strong</a:t>
+            </a:r>
+            <a:r>
+              <a:rPr lang="en-US" altLang="zh-CN" sz="2800" dirty="0"/>
+              <a:t> (</a:t>
+            </a:r>
+            <a:r>
+              <a:rPr lang="en-US" altLang="zh-CN" sz="2400" dirty="0"/>
+              <a:t>What are needed for Agent)</a:t>
+            </a:r>
+            <a:endParaRPr lang="en-US" altLang="zh-CN" dirty="0"/>
+          </a:p>
+        </p:txBody>
+      </p:sp>
+      <p:sp>
+        <p:nvSpPr>
+          <p:cNvPr id="6" name="文本框 5">
+            <a:extLst>
+              <a:ext uri="{FF2B5EF4-FFF2-40B4-BE49-F238E27FC236}">
+                <a16:creationId xmlns:a16="http://schemas.microsoft.com/office/drawing/2014/main" id="{BE764E19-EC7F-A01E-90EC-4D0ACFC44950}"/>
+              </a:ext>
+            </a:extLst>
+          </p:cNvPr>
+          <p:cNvSpPr txBox="1"/>
+          <p:nvPr/>
+        </p:nvSpPr>
+        <p:spPr>
+          <a:xfrm>
+            <a:off x="955503" y="1381794"/>
+            <a:ext cx="10769601" cy="3374129"/>
+          </a:xfrm>
+          <a:prstGeom prst="rect">
+            <a:avLst/>
+          </a:prstGeom>
+          <a:noFill/>
+        </p:spPr>
+        <p:txBody>
+          <a:bodyPr wrap="square">
+            <a:spAutoFit/>
+          </a:bodyPr>
+          <a:lstStyle/>
+          <a:p>
+            <a:pPr marL="285750" indent="-285750">
+              <a:lnSpc>
+                <a:spcPct val="150000"/>
+              </a:lnSpc>
+              <a:buFont typeface="Arial" panose="020B0604020202020204" pitchFamily="34" charset="0"/>
+              <a:buChar char="•"/>
+            </a:pPr>
+            <a:r>
+              <a:rPr lang="en-US" altLang="zh-CN" dirty="0"/>
+              <a:t>It is strong because </a:t>
+            </a:r>
+            <a:r>
+              <a:rPr lang="en-US" altLang="zh-CN" b="1" dirty="0"/>
+              <a:t>it knows how to give the model a working environment that fits the task</a:t>
+            </a:r>
+            <a:r>
+              <a:rPr lang="en-US" altLang="zh-CN" dirty="0"/>
+              <a:t>. Concretely, that environment work includes:</a:t>
+            </a:r>
+          </a:p>
+          <a:p>
+            <a:pPr marL="285750" indent="-285750">
+              <a:lnSpc>
+                <a:spcPct val="150000"/>
+              </a:lnSpc>
+              <a:buFont typeface="Arial" panose="020B0604020202020204" pitchFamily="34" charset="0"/>
+              <a:buChar char="•"/>
+            </a:pPr>
+            <a:endParaRPr lang="en-US" altLang="zh-CN" dirty="0"/>
+          </a:p>
+          <a:p>
+            <a:pPr marL="285750" indent="-285750">
+              <a:lnSpc>
+                <a:spcPct val="150000"/>
+              </a:lnSpc>
+              <a:buFont typeface="Arial" panose="020B0604020202020204" pitchFamily="34" charset="0"/>
+              <a:buChar char="•"/>
+            </a:pPr>
+            <a:r>
+              <a:rPr lang="en-US" altLang="zh-CN" dirty="0"/>
+              <a:t>How to </a:t>
+            </a:r>
+            <a:r>
+              <a:rPr lang="en-US" altLang="zh-CN" b="1" dirty="0"/>
+              <a:t>manage context</a:t>
+            </a:r>
+            <a:r>
+              <a:rPr lang="en-US" altLang="zh-CN" dirty="0"/>
+              <a:t> (compaction, system prompts, memory).</a:t>
+            </a:r>
+          </a:p>
+          <a:p>
+            <a:pPr marL="285750" indent="-285750">
+              <a:lnSpc>
+                <a:spcPct val="150000"/>
+              </a:lnSpc>
+              <a:buFont typeface="Arial" panose="020B0604020202020204" pitchFamily="34" charset="0"/>
+              <a:buChar char="•"/>
+            </a:pPr>
+            <a:r>
+              <a:rPr lang="en-US" altLang="zh-CN" dirty="0"/>
+              <a:t>How to </a:t>
+            </a:r>
+            <a:r>
+              <a:rPr lang="en-US" altLang="zh-CN" b="1" dirty="0"/>
+              <a:t>isolate task pollution</a:t>
+            </a:r>
+            <a:r>
+              <a:rPr lang="en-US" altLang="zh-CN" dirty="0"/>
+              <a:t> (subagents, </a:t>
+            </a:r>
+            <a:r>
+              <a:rPr lang="en-US" altLang="zh-CN" dirty="0" err="1"/>
+              <a:t>worktrees</a:t>
+            </a:r>
+            <a:r>
+              <a:rPr lang="en-US" altLang="zh-CN" dirty="0"/>
+              <a:t>).</a:t>
+            </a:r>
+          </a:p>
+          <a:p>
+            <a:pPr marL="285750" indent="-285750">
+              <a:lnSpc>
+                <a:spcPct val="150000"/>
+              </a:lnSpc>
+              <a:buFont typeface="Arial" panose="020B0604020202020204" pitchFamily="34" charset="0"/>
+              <a:buChar char="•"/>
+            </a:pPr>
+            <a:r>
+              <a:rPr lang="en-US" altLang="zh-CN" dirty="0"/>
+              <a:t>How to </a:t>
+            </a:r>
+            <a:r>
+              <a:rPr lang="en-US" altLang="zh-CN" b="1" dirty="0"/>
+              <a:t>maintain state</a:t>
+            </a:r>
+            <a:r>
+              <a:rPr lang="en-US" altLang="zh-CN" dirty="0"/>
+              <a:t> (scratchpad files, </a:t>
+            </a:r>
+            <a:r>
+              <a:rPr lang="en-US" altLang="zh-CN" dirty="0" err="1"/>
+              <a:t>todos</a:t>
+            </a:r>
+            <a:r>
+              <a:rPr lang="en-US" altLang="zh-CN" dirty="0"/>
+              <a:t>, plans).</a:t>
+            </a:r>
+          </a:p>
+          <a:p>
+            <a:pPr marL="285750" indent="-285750">
+              <a:lnSpc>
+                <a:spcPct val="150000"/>
+              </a:lnSpc>
+              <a:buFont typeface="Arial" panose="020B0604020202020204" pitchFamily="34" charset="0"/>
+              <a:buChar char="•"/>
+            </a:pPr>
+            <a:r>
+              <a:rPr lang="en-US" altLang="zh-CN" dirty="0"/>
+              <a:t>How to </a:t>
+            </a:r>
+            <a:r>
+              <a:rPr lang="en-US" altLang="zh-CN" b="1" dirty="0"/>
+              <a:t>compress information</a:t>
+            </a:r>
+            <a:r>
+              <a:rPr lang="en-US" altLang="zh-CN" dirty="0"/>
+              <a:t> (skills, summaries).</a:t>
+            </a:r>
+          </a:p>
+          <a:p>
+            <a:pPr marL="285750" indent="-285750">
+              <a:lnSpc>
+                <a:spcPct val="150000"/>
+              </a:lnSpc>
+              <a:buFont typeface="Arial" panose="020B0604020202020204" pitchFamily="34" charset="0"/>
+              <a:buChar char="•"/>
+            </a:pPr>
+            <a:r>
+              <a:rPr lang="en-US" altLang="zh-CN" dirty="0"/>
+              <a:t>How to </a:t>
+            </a:r>
+            <a:r>
+              <a:rPr lang="en-US" altLang="zh-CN" b="1" dirty="0"/>
+              <a:t>keep the model focused on the goal</a:t>
+            </a:r>
+            <a:r>
+              <a:rPr lang="en-US" altLang="zh-CN" dirty="0"/>
+              <a:t> (planning, structured outputs, periodic re-anchoring).</a:t>
+            </a:r>
+          </a:p>
+        </p:txBody>
+      </p:sp>
+    </p:spTree>
+    <p:extLst>
+      <p:ext uri="{BB962C8B-B14F-4D97-AF65-F5344CB8AC3E}">
+        <p14:creationId xmlns:p14="http://schemas.microsoft.com/office/powerpoint/2010/main" val="2937530592"/>
+      </p:ext>
+    </p:extLst>
+  </p:cSld>
+  <p:clrMapOvr>
+    <a:masterClrMapping/>
+  </p:clrMapOvr>
+</p:sld>
+</file>
+
+<file path=ppt/slides/slide18.xml><?xml version="1.0" encoding="utf-8"?>
+<p:sld xmlns:a="http://schemas.openxmlformats.org/drawingml/2006/main" xmlns:r="http://schemas.openxmlformats.org/officeDocument/2006/relationships" xmlns:p="http://schemas.openxmlformats.org/presentationml/2006/main">
+  <p:cSld>
+    <p:spTree>
+      <p:nvGrpSpPr>
+        <p:cNvPr id="1" name="">
+          <a:extLst>
+            <a:ext uri="{FF2B5EF4-FFF2-40B4-BE49-F238E27FC236}">
+              <a16:creationId xmlns:a16="http://schemas.microsoft.com/office/drawing/2014/main" id="{FB0ABD15-7E8E-230A-CC2F-A90ACB1F4CCB}"/>
+            </a:ext>
+          </a:extLst>
+        </p:cNvPr>
+        <p:cNvGrpSpPr/>
+        <p:nvPr/>
+      </p:nvGrpSpPr>
+      <p:grpSpPr>
+        <a:xfrm>
+          <a:off x="0" y="0"/>
+          <a:ext cx="0" cy="0"/>
+          <a:chOff x="0" y="0"/>
+          <a:chExt cx="0" cy="0"/>
+        </a:xfrm>
+      </p:grpSpPr>
+      <p:sp>
+        <p:nvSpPr>
+          <p:cNvPr id="2" name="标题 1">
+            <a:extLst>
+              <a:ext uri="{FF2B5EF4-FFF2-40B4-BE49-F238E27FC236}">
+                <a16:creationId xmlns:a16="http://schemas.microsoft.com/office/drawing/2014/main" id="{6E77652D-A71C-AD7A-7E7F-1089BD75873A}"/>
+              </a:ext>
+            </a:extLst>
+          </p:cNvPr>
+          <p:cNvSpPr>
+            <a:spLocks noGrp="1"/>
+          </p:cNvSpPr>
+          <p:nvPr>
+            <p:ph type="title"/>
+          </p:nvPr>
+        </p:nvSpPr>
+        <p:spPr>
+          <a:xfrm>
+            <a:off x="838200" y="125639"/>
+            <a:ext cx="10515600" cy="1325563"/>
+          </a:xfrm>
+        </p:spPr>
+        <p:txBody>
+          <a:bodyPr/>
+          <a:lstStyle/>
+          <a:p>
+            <a:r>
+              <a:rPr lang="en-US" altLang="zh-CN" dirty="0"/>
+              <a:t>What to Think During Agent Building</a:t>
+            </a:r>
+          </a:p>
+        </p:txBody>
+      </p:sp>
+      <p:sp>
+        <p:nvSpPr>
+          <p:cNvPr id="6" name="文本框 5">
+            <a:extLst>
+              <a:ext uri="{FF2B5EF4-FFF2-40B4-BE49-F238E27FC236}">
+                <a16:creationId xmlns:a16="http://schemas.microsoft.com/office/drawing/2014/main" id="{872F6B8A-5317-F457-719C-85C10C8C330F}"/>
+              </a:ext>
+            </a:extLst>
+          </p:cNvPr>
+          <p:cNvSpPr txBox="1"/>
+          <p:nvPr/>
+        </p:nvSpPr>
+        <p:spPr>
+          <a:xfrm>
+            <a:off x="955503" y="1381794"/>
+            <a:ext cx="10769601" cy="5867119"/>
+          </a:xfrm>
+          <a:prstGeom prst="rect">
+            <a:avLst/>
+          </a:prstGeom>
+          <a:noFill/>
+        </p:spPr>
+        <p:txBody>
+          <a:bodyPr wrap="square">
+            <a:spAutoFit/>
+          </a:bodyPr>
+          <a:lstStyle/>
+          <a:p>
+            <a:pPr marL="342900" indent="-342900">
+              <a:lnSpc>
+                <a:spcPct val="150000"/>
+              </a:lnSpc>
+              <a:buFont typeface="+mj-lt"/>
+              <a:buAutoNum type="arabicPeriod"/>
+            </a:pPr>
+            <a:r>
+              <a:rPr lang="en-US" altLang="zh-CN" dirty="0"/>
+              <a:t>Start every feature proposal with "does the LLM need this? / What burden it adds and removed?" </a:t>
+            </a:r>
+          </a:p>
+          <a:p>
+            <a:pPr marL="342900" indent="-342900">
+              <a:lnSpc>
+                <a:spcPct val="150000"/>
+              </a:lnSpc>
+              <a:buFont typeface="+mj-lt"/>
+              <a:buAutoNum type="arabicPeriod"/>
+            </a:pPr>
+            <a:r>
+              <a:rPr lang="en-US" altLang="zh-CN" dirty="0"/>
+              <a:t>Having an externalized working memory beats clever prompting for remember what to do.</a:t>
+            </a:r>
+          </a:p>
+          <a:p>
+            <a:pPr marL="342900" indent="-342900">
+              <a:lnSpc>
+                <a:spcPct val="150000"/>
+              </a:lnSpc>
+              <a:buFont typeface="+mj-lt"/>
+              <a:buAutoNum type="arabicPeriod"/>
+            </a:pPr>
+            <a:r>
+              <a:rPr lang="en-US" altLang="zh-CN" dirty="0"/>
+              <a:t>Wired your agent into the team’s/user’s real workflows, conventions, and constraints.</a:t>
+            </a:r>
+          </a:p>
+          <a:p>
+            <a:pPr marL="285750" indent="-285750">
+              <a:lnSpc>
+                <a:spcPct val="150000"/>
+              </a:lnSpc>
+              <a:buFont typeface="Arial" panose="020B0604020202020204" pitchFamily="34" charset="0"/>
+              <a:buChar char="•"/>
+            </a:pPr>
+            <a:endParaRPr lang="en-US" altLang="zh-CN" dirty="0"/>
+          </a:p>
+          <a:p>
+            <a:pPr marL="285750" indent="-285750">
+              <a:lnSpc>
+                <a:spcPct val="150000"/>
+              </a:lnSpc>
+              <a:buFont typeface="Arial" panose="020B0604020202020204" pitchFamily="34" charset="0"/>
+              <a:buChar char="•"/>
+            </a:pPr>
+            <a:r>
+              <a:rPr lang="en-US" altLang="zh-CN" b="1" dirty="0"/>
+              <a:t>Embed deeper into real workflows</a:t>
+            </a:r>
+            <a:r>
+              <a:rPr lang="en-US" altLang="zh-CN" dirty="0"/>
+              <a:t> — GitLab, Jira, CI/CD, on-call, code review — not just chat windows.</a:t>
+            </a:r>
+          </a:p>
+          <a:p>
+            <a:pPr marL="285750" indent="-285750">
+              <a:lnSpc>
+                <a:spcPct val="150000"/>
+              </a:lnSpc>
+              <a:buFont typeface="Arial" panose="020B0604020202020204" pitchFamily="34" charset="0"/>
+              <a:buChar char="•"/>
+            </a:pPr>
+            <a:r>
+              <a:rPr lang="en-US" altLang="zh-CN" b="1" dirty="0"/>
+              <a:t>Maintain cognitive state more stably</a:t>
+            </a:r>
+            <a:r>
+              <a:rPr lang="en-US" altLang="zh-CN" dirty="0"/>
+              <a:t> — continuous records of task stages, decisions made, decisions deferred, so a fresh session can resume without losing the thread.</a:t>
+            </a:r>
+          </a:p>
+          <a:p>
+            <a:pPr marL="285750" indent="-285750">
+              <a:lnSpc>
+                <a:spcPct val="150000"/>
+              </a:lnSpc>
+              <a:buFont typeface="Arial" panose="020B0604020202020204" pitchFamily="34" charset="0"/>
+              <a:buChar char="•"/>
+            </a:pPr>
+            <a:r>
+              <a:rPr lang="en-US" altLang="zh-CN" b="1" dirty="0"/>
+              <a:t>Acquire context more cheaply</a:t>
+            </a:r>
+            <a:r>
+              <a:rPr lang="en-US" altLang="zh-CN" dirty="0"/>
+              <a:t> — auto-generated call chains, key entry points, dependency maps so the model doesn't have to rediscover the codebase every time.</a:t>
+            </a:r>
+          </a:p>
+          <a:p>
+            <a:pPr marL="285750" indent="-285750">
+              <a:lnSpc>
+                <a:spcPct val="150000"/>
+              </a:lnSpc>
+              <a:buFont typeface="Arial" panose="020B0604020202020204" pitchFamily="34" charset="0"/>
+              <a:buChar char="•"/>
+            </a:pPr>
+            <a:r>
+              <a:rPr lang="en-US" altLang="zh-CN" b="1" dirty="0"/>
+              <a:t>Organize long-term memory better</a:t>
+            </a:r>
+            <a:r>
+              <a:rPr lang="en-US" altLang="zh-CN" dirty="0"/>
+              <a:t> — historical bugs, architectural decisions, "why we did X this way" precipitated into something retrievable.</a:t>
+            </a:r>
+          </a:p>
+          <a:p>
+            <a:pPr marL="285750" indent="-285750">
+              <a:lnSpc>
+                <a:spcPct val="150000"/>
+              </a:lnSpc>
+              <a:buFont typeface="Arial" panose="020B0604020202020204" pitchFamily="34" charset="0"/>
+              <a:buChar char="•"/>
+            </a:pPr>
+            <a:r>
+              <a:rPr lang="en-US" altLang="zh-CN" b="1" dirty="0"/>
+              <a:t>Understand organizational rules accurately</a:t>
+            </a:r>
+            <a:r>
+              <a:rPr lang="en-US" altLang="zh-CN" dirty="0"/>
+              <a:t> — approval chains, permission boundaries, process constraints. Knowing what </a:t>
+            </a:r>
+            <a:r>
+              <a:rPr lang="en-US" altLang="zh-CN" i="1" dirty="0"/>
+              <a:t>cannot</a:t>
+            </a:r>
+            <a:r>
+              <a:rPr lang="en-US" altLang="zh-CN" dirty="0"/>
+              <a:t> be done autonomously is as important as knowing what </a:t>
+            </a:r>
+            <a:r>
+              <a:rPr lang="en-US" altLang="zh-CN" i="1" dirty="0"/>
+              <a:t>can</a:t>
+            </a:r>
+            <a:r>
+              <a:rPr lang="en-US" altLang="zh-CN" dirty="0"/>
+              <a:t>.</a:t>
+            </a:r>
+          </a:p>
+          <a:p>
+            <a:pPr marL="285750" indent="-285750">
+              <a:lnSpc>
+                <a:spcPct val="150000"/>
+              </a:lnSpc>
+              <a:buFont typeface="Arial" panose="020B0604020202020204" pitchFamily="34" charset="0"/>
+              <a:buChar char="•"/>
+            </a:pPr>
+            <a:endParaRPr lang="en-US" altLang="zh-CN" dirty="0"/>
+          </a:p>
+        </p:txBody>
+      </p:sp>
+    </p:spTree>
+    <p:extLst>
+      <p:ext uri="{BB962C8B-B14F-4D97-AF65-F5344CB8AC3E}">
+        <p14:creationId xmlns:p14="http://schemas.microsoft.com/office/powerpoint/2010/main" val="277764317"/>
       </p:ext>
     </p:extLst>
   </p:cSld>

</xml_diff>